<commit_message>
Fill in applicant identity across grant kit
About me / Team sections in all three drafts now carry the real
applicant (Josh Simnitt · jsimnitt@gmail.com · github.com/star7js),
pointing reviewers at the commit history as evidence and openly
noting AI-assisted development. Deck and one-pager rebuilt with the
same contact details on title/close/footer. STATUS.md checklist
updated accordingly.

Co-Authored-By: Claude Fable 5 <noreply@anthropic.com>
Claude-Session: https://claude.ai/code/session_01EydEYTHSzMe1wCaLUfNi8i
</commit_message>
<xml_diff>
--- a/docs/grants/sentinel-pitch.pptx
+++ b/docs/grants/sentinel-pitch.pptx
@@ -513,7 +513,7 @@
           <a:p>
             <a:r>
               <a:rPr lang="en-US" dirty="0"/>
-              <a:t>Open with the one-liner: Sentinel sits between an AI agent and its signer and refuses to sign anything that violates policy, fails simulation, or touches known-malicious addresses. Key framing for any grant audience: this is not an idea seeking funding to be built — it is built, tested, and publicly verifiable; the funding buys assurance and adoption. TAILOR BEFORE PRESENTING: add your name/handle under the title, and check the ask slide numbers against the program you are pitching.</a:t>
+              <a:t>Open with the one-liner: Sentinel sits between an AI agent and its signer and refuses to sign anything that violates policy, fails simulation, or touches known-malicious addresses. Key framing for any grant audience: this is not an idea seeking funding to be built — it is built, tested, and publicly verifiable; the funding buys assurance and adoption. TAILOR BEFORE PRESENTING: check the ask slide numbers against the program you are pitching.</a:t>
             </a:r>
             <a:endParaRPr lang="en-US" dirty="0"/>
           </a:p>
@@ -777,7 +777,7 @@
           <a:p>
             <a:r>
               <a:rPr lang="en-US" dirty="0"/>
-              <a:t>End on the three-beat close and stop talking. BEFORE SHARING: (1) add your name and contact here and on the title slide; (2) confirm the ask numbers per program; (3) if presenting live, have anvil installed so npm run demo works on the spot. The full submission checklist lives in docs/STATUS.md in the repo.</a:t>
+              <a:t>End on the three-beat close and stop talking. BEFORE SHARING: (1) confirm the ask numbers per program; (2) if presenting live, have anvil installed so npm run demo works on the spot. The full submission checklist lives in docs/STATUS.md in the repo.</a:t>
             </a:r>
             <a:endParaRPr lang="en-US" dirty="0"/>
           </a:p>
@@ -2051,7 +2051,46 @@
         </p:nvSpPr>
         <p:spPr>
           <a:xfrm>
-            <a:off x="822960" y="6035040"/>
+            <a:off x="822960" y="5715000"/>
+            <a:ext cx="10515600" cy="365760"/>
+          </a:xfrm>
+          <a:prstGeom prst="rect">
+            <a:avLst/>
+          </a:prstGeom>
+          <a:noFill/>
+          <a:ln/>
+        </p:spPr>
+        <p:txBody>
+          <a:bodyPr wrap="square" lIns="0" tIns="0" rIns="0" bIns="0" rtlCol="0" anchor="ctr"/>
+          <a:lstStyle/>
+          <a:p>
+            <a:pPr indent="0" marL="0">
+              <a:buNone/>
+            </a:pPr>
+            <a:r>
+              <a:rPr lang="en-US" sz="1400" dirty="0">
+                <a:solidFill>
+                  <a:srgbClr val="C4D4EA"/>
+                </a:solidFill>
+                <a:latin typeface="Calibri" pitchFamily="34" charset="0"/>
+                <a:ea typeface="Calibri" pitchFamily="34" charset="-122"/>
+                <a:cs typeface="Calibri" pitchFamily="34" charset="-120"/>
+              </a:rPr>
+              <a:t>Josh Simnitt   ·   jsimnitt@gmail.com   ·   github.com/star7js</a:t>
+            </a:r>
+            <a:endParaRPr lang="en-US" sz="1400" dirty="0"/>
+          </a:p>
+        </p:txBody>
+      </p:sp>
+      <p:sp>
+        <p:nvSpPr>
+          <p:cNvPr id="8" name="Text 5"/>
+          <p:cNvSpPr/>
+          <p:nvPr/>
+        </p:nvSpPr>
+        <p:spPr>
+          <a:xfrm>
+            <a:off x="822960" y="6144768"/>
             <a:ext cx="10515600" cy="365760"/>
           </a:xfrm>
           <a:prstGeom prst="rect">
@@ -3526,7 +3565,7 @@
                 <a:ea typeface="Calibri" pitchFamily="34" charset="-122"/>
                 <a:cs typeface="Calibri" pitchFamily="34" charset="-120"/>
               </a:rPr>
-              <a:t>sentinel-firewall on npm   ·   MIT   ·   docs/STATUS.md for where everything stands</a:t>
+              <a:t>Josh Simnitt   ·   jsimnitt@gmail.com   ·   sentinel-firewall on npm   ·   MIT</a:t>
             </a:r>
             <a:endParaRPr lang="en-US" sz="1300" dirty="0"/>
           </a:p>

</xml_diff>